<commit_message>
Drop the asks from the closing slide
The direction comes from the meeting, not from a request list on a
slide. The last slide now carries only what landed, what is next and
how the deck grows.

Co-Authored-By: Claude Fable 5.1 <noreply@anthropic.com>
Claude-Session: https://claude.ai/code/session_01UiTC1BeuJK5BZLbarMcqjw
</commit_message>
<xml_diff>
--- a/deck/amc_progress.pptx
+++ b/deck/amc_progress.pptx
@@ -9877,7 +9877,7 @@
                 <a:ea typeface="Cambria" pitchFamily="34" charset="-122"/>
                 <a:cs typeface="Cambria" pitchFamily="34" charset="-120"/>
               </a:rPr>
-              <a:t>Next, and what would help</a:t>
+              <a:t>Next</a:t>
             </a:r>
             <a:endParaRPr lang="en-US" sz="3000" dirty="0"/>
           </a:p>
@@ -9931,7 +9931,7 @@
         <p:spPr>
           <a:xfrm>
             <a:off x="2651760" y="1463040"/>
-            <a:ext cx="4206240" cy="1097280"/>
+            <a:ext cx="8988552" cy="1097280"/>
           </a:xfrm>
           <a:prstGeom prst="rect">
             <a:avLst/>
@@ -10009,7 +10009,7 @@
         <p:spPr>
           <a:xfrm>
             <a:off x="2651760" y="2697480"/>
-            <a:ext cx="4206240" cy="1097280"/>
+            <a:ext cx="8988552" cy="1097280"/>
           </a:xfrm>
           <a:prstGeom prst="rect">
             <a:avLst/>
@@ -10087,7 +10087,7 @@
         <p:spPr>
           <a:xfrm>
             <a:off x="2651760" y="3931920"/>
-            <a:ext cx="4206240" cy="1097280"/>
+            <a:ext cx="8988552" cy="1097280"/>
           </a:xfrm>
           <a:prstGeom prst="rect">
             <a:avLst/>
@@ -10119,158 +10119,7 @@
       </p:sp>
       <p:sp>
         <p:nvSpPr>
-          <p:cNvPr id="9" name="Shape 7"/>
-          <p:cNvSpPr/>
-          <p:nvPr/>
-        </p:nvSpPr>
-        <p:spPr>
-          <a:xfrm>
-            <a:off x="7132320" y="1417320"/>
-            <a:ext cx="4572000" cy="4206240"/>
-          </a:xfrm>
-          <a:prstGeom prst="roundRect">
-            <a:avLst>
-              <a:gd name="adj" fmla="val 1739"/>
-            </a:avLst>
-          </a:prstGeom>
-          <a:solidFill>
-            <a:srgbClr val="13315C"/>
-          </a:solidFill>
-          <a:ln w="12700">
-            <a:solidFill>
-              <a:srgbClr val="13315C"/>
-            </a:solidFill>
-            <a:prstDash val="solid"/>
-          </a:ln>
-        </p:spPr>
-      </p:sp>
-      <p:sp>
-        <p:nvSpPr>
-          <p:cNvPr id="10" name="Text 8"/>
-          <p:cNvSpPr txBox="1"/>
-          <p:nvPr/>
-        </p:nvSpPr>
-        <p:spPr>
-          <a:xfrm>
-            <a:off x="7360920" y="1554480"/>
-            <a:ext cx="4114800" cy="411480"/>
-          </a:xfrm>
-          <a:prstGeom prst="rect">
-            <a:avLst/>
-          </a:prstGeom>
-          <a:noFill/>
-          <a:ln/>
-        </p:spPr>
-        <p:txBody>
-          <a:bodyPr wrap="square" lIns="0" tIns="0" rIns="0" bIns="0" rtlCol="0" anchor="ctr"/>
-          <a:lstStyle/>
-          <a:p>
-            <a:pPr indent="0" marL="0">
-              <a:buNone/>
-            </a:pPr>
-            <a:r>
-              <a:rPr lang="en-US" sz="1800" b="1" dirty="0">
-                <a:solidFill>
-                  <a:srgbClr val="FFFFFF"/>
-                </a:solidFill>
-                <a:latin typeface="Cambria" pitchFamily="34" charset="0"/>
-                <a:ea typeface="Cambria" pitchFamily="34" charset="-122"/>
-                <a:cs typeface="Cambria" pitchFamily="34" charset="-120"/>
-              </a:rPr>
-              <a:t>Asks</a:t>
-            </a:r>
-            <a:endParaRPr lang="en-US" sz="1800" dirty="0"/>
-          </a:p>
-        </p:txBody>
-      </p:sp>
-      <p:sp>
-        <p:nvSpPr>
-          <p:cNvPr id="11" name="Text 9"/>
-          <p:cNvSpPr txBox="1"/>
-          <p:nvPr/>
-        </p:nvSpPr>
-        <p:spPr>
-          <a:xfrm>
-            <a:off x="7360920" y="2057400"/>
-            <a:ext cx="4114800" cy="3474720"/>
-          </a:xfrm>
-          <a:prstGeom prst="rect">
-            <a:avLst/>
-          </a:prstGeom>
-          <a:noFill/>
-          <a:ln/>
-        </p:spPr>
-        <p:txBody>
-          <a:bodyPr wrap="square" lIns="0" tIns="0" rIns="0" bIns="0" rtlCol="0" anchor="t"/>
-          <a:lstStyle/>
-          <a:p>
-            <a:pPr marL="342900" indent="-342900">
-              <a:spcAft>
-                <a:spcPts val="600"/>
-              </a:spcAft>
-              <a:buSzPct val="100000"/>
-              <a:buChar char="•"/>
-            </a:pPr>
-            <a:r>
-              <a:rPr lang="en-US" sz="1250" dirty="0">
-                <a:solidFill>
-                  <a:srgbClr val="FFFFFF"/>
-                </a:solidFill>
-                <a:latin typeface="Calibri" pitchFamily="34" charset="0"/>
-                <a:ea typeface="Calibri" pitchFamily="34" charset="-122"/>
-                <a:cs typeface="Calibri" pitchFamily="34" charset="-120"/>
-              </a:rPr>
-              <a:t>SDR access — a USRP or HackRF and a capture protocol. The one thing that turns this from a study into a result.</a:t>
-            </a:r>
-            <a:endParaRPr lang="en-US" sz="1250" dirty="0"/>
-          </a:p>
-          <a:p>
-            <a:pPr marL="342900" indent="-342900">
-              <a:spcAft>
-                <a:spcPts val="600"/>
-              </a:spcAft>
-              <a:buSzPct val="100000"/>
-              <a:buChar char="•"/>
-            </a:pPr>
-            <a:r>
-              <a:rPr lang="en-US" sz="1250" dirty="0">
-                <a:solidFill>
-                  <a:srgbClr val="FFFFFF"/>
-                </a:solidFill>
-                <a:latin typeface="Calibri" pitchFamily="34" charset="0"/>
-                <a:ea typeface="Calibri" pitchFamily="34" charset="-122"/>
-                <a:cs typeface="Calibri" pitchFamily="34" charset="-120"/>
-              </a:rPr>
-              <a:t>Open-set recognition literature: the field adjacent to the sink finding. Who should I be reading?</a:t>
-            </a:r>
-            <a:endParaRPr lang="en-US" sz="1250" dirty="0"/>
-          </a:p>
-          <a:p>
-            <a:pPr marL="342900" indent="-342900">
-              <a:spcAft>
-                <a:spcPts val="600"/>
-              </a:spcAft>
-              <a:buSzPct val="100000"/>
-              <a:buChar char="•"/>
-            </a:pPr>
-            <a:r>
-              <a:rPr lang="en-US" sz="1250" dirty="0">
-                <a:solidFill>
-                  <a:srgbClr val="FFFFFF"/>
-                </a:solidFill>
-                <a:latin typeface="Calibri" pitchFamily="34" charset="0"/>
-                <a:ea typeface="Calibri" pitchFamily="34" charset="-122"/>
-                <a:cs typeface="Calibri" pitchFamily="34" charset="-120"/>
-              </a:rPr>
-              <a:t>Target venue: the contribution is an attribution method, not a benchmark number. Signal processing or machine learning?</a:t>
-            </a:r>
-            <a:endParaRPr lang="en-US" sz="1250" dirty="0"/>
-          </a:p>
-        </p:txBody>
-      </p:sp>
-      <p:sp>
-        <p:nvSpPr>
-          <p:cNvPr id="12" name="Text 10"/>
+          <p:cNvPr id="9" name="Text 7"/>
           <p:cNvSpPr txBox="1"/>
           <p:nvPr/>
         </p:nvSpPr>
@@ -10309,7 +10158,7 @@
       </p:sp>
       <p:sp>
         <p:nvSpPr>
-          <p:cNvPr id="13" name="Text 11"/>
+          <p:cNvPr id="10" name="Text 8"/>
           <p:cNvSpPr txBox="1"/>
           <p:nvPr/>
         </p:nvSpPr>

</xml_diff>

<commit_message>
Speaker script for the progress deck
talk.js carries one paragraph per slide; build.js writes it into each
slide's notes, and TALK.md is the same script with timing and a sheet
of the questions to expect, each answered with the count behind the
number.

Co-Authored-By: Claude Fable 5.1 <noreply@anthropic.com>
Claude-Session: https://claude.ai/code/session_01UiTC1BeuJK5BZLbarMcqjw
</commit_message>
<xml_diff>
--- a/deck/amc_progress.pptx
+++ b/deck/amc_progress.pptx
@@ -3376,7 +3376,8 @@
           <a:p>
             <a:r>
               <a:rPr lang="en-US" dirty="0"/>
-              <a:t>Every number in this deck is read from a results file in the repository; nothing is quoted from the earlier backbone.</a:t>
+              <a:t>This is a progress report on one question: why a modulation classifier that is nearly perfect on its training data fails when the transmitter changes, and what actually fixes it. Everything I show is measured on one dataset and one model, and every number comes from a file in the repository.
+Every number in this deck is read from a results file in the repository; nothing is quoted from the earlier backbone.</a:t>
             </a:r>
             <a:endParaRPr lang="en-US" dirty="0"/>
           </a:p>
@@ -3464,7 +3465,8 @@
           <a:p>
             <a:r>
               <a:rPr lang="en-US" dirty="0"/>
-              <a:t>The middle of the sweep is where seeds disagree: α = 0.5 has a spread of 0.019 on cross-domain accuracy against 0.001–0.007 at either end. Half-removing the envelope leaves a model that sometimes learns to read through it.</a:t>
+              <a:t>So the fix removes the envelope: divide each frame's spectrum by a smoothed estimate of its own magnitude. Alpha is how much of it. Cross-domain accuracy goes 0.805, 0.855, 0.940, 0.988, 0.993 for alpha 0 to 1. The recovery is entirely 16QAM: its recall goes from 0.056 to 0.985. And it costs nothing in-domain, 0.999 stays 0.999.
+The middle of the sweep is where seeds disagree: α = 0.5 has a spread of 0.019 on cross-domain accuracy against 0.001–0.007 at either end. Half-removing the envelope leaves a model that sometimes learns to read through it.</a:t>
             </a:r>
             <a:endParaRPr lang="en-US" dirty="0"/>
           </a:p>
@@ -3552,7 +3554,8 @@
           <a:p>
             <a:r>
               <a:rPr lang="en-US" dirty="0"/>
-              <a:t>The ICRNNA column of the control is a bit-identical training to the corresponding rows of the 24-class run: same best epoch, same in-distribution accuracy to every digit. The probe frames are an independent draw and move the shares by at most 0.3 points.</a:t>
+              <a:t>Where does a modulation the model never saw go. Train on 23 classes, probe with the 24th, record which class absorbs it. Families were fixed before the run. 16 of 24 land in their own family; chance is 3.5. All 24 runs converged. The eight misses are on the table. Four of them are APSK versus QAM, both amplitude-and-phase constellations; two are FM versus GMSK, both constant envelope. So the misses are structured, but I quote 16, not a rescored 20, because the families were fixed in advance. On the right: the same test on five architectures. Same-family sink survives on all of them.
+The ICRNNA column of the control is a bit-identical training to the corresponding rows of the 24-class run: same best epoch, same in-distribution accuracy to every digit. The probe frames are an independent draw and move the shares by at most 0.3 points.</a:t>
             </a:r>
             <a:endParaRPr lang="en-US" dirty="0"/>
           </a:p>
@@ -3640,7 +3643,8 @@
           <a:p>
             <a:r>
               <a:rPr lang="en-US" dirty="0"/>
-              <a:t>Negative results are part of the argument. Whitening itself is not novel either: WhiteNet arrived at the same operation on real over-the-air captures; what survives here is the attribution method and the sink finding.</a:t>
+              <a:t>Three things this rerun took away. They are kept in the record. Partial whitening beats full: withdrawn, alpha 1 is at least as good as 0.75. The model reads the class off the envelope: withdrawn, giving 16QAM a 64QAM envelope leaves the prediction at 16QAM, so the mechanism is open. The 60-epoch ceiling was safe: it was not, cells peaked at 82 to 89, and the rerun with room came back bit-identical or within a point.
+Negative results are part of the argument. Whitening itself is not novel either: WhiteNet arrived at the same operation on real over-the-air captures; what survives here is the attribution method and the sink finding.</a:t>
             </a:r>
             <a:endParaRPr lang="en-US" dirty="0"/>
           </a:p>
@@ -3728,7 +3732,8 @@
           <a:p>
             <a:r>
               <a:rPr lang="en-US" dirty="0"/>
-              <a:t/>
+              <a:t>Caveats. Both domains are synthetic; until we have an over-the-air capture this is a study of a mechanism. The model is not the published architecture; a paper-faithful build exists and reproduces the paper's 63.24 to within 0.03, but only trained to convergence. Half of the sink checks are still on the old model. And three seeds is thin on 24 classes: under about 0.03 a difference is not a difference.
+</a:t>
             </a:r>
             <a:endParaRPr lang="en-US" dirty="0"/>
           </a:p>
@@ -3816,7 +3821,8 @@
           <a:p>
             <a:r>
               <a:rPr lang="en-US" dirty="0"/>
-              <a:t/>
+              <a:t>What just landed is the sink thread. Next is the domain-adversarial baseline, port or drop, and the cumulant classifier on the same four classes at 0 dB, to check whether the QAM coin flip is the signal's limit or the model's. The deck is the running record: new results get appended, withdrawn claims stay.
+</a:t>
             </a:r>
             <a:endParaRPr lang="en-US" dirty="0"/>
           </a:p>
@@ -3904,7 +3910,8 @@
           <a:p>
             <a:r>
               <a:rPr lang="en-US" dirty="0"/>
-              <a:t>The contribution is the attribution method, not an accuracy number. The 0.999 to 0.805 drop is the starting measurement, on five shared classes, five seeds.</a:t>
+              <a:t>The setup. Train on RadioML. Then test on I/Q from a different transmitter model: same five modulations, same SNRs, same sample rate. In-domain the model is at 0.999. On the other transmitter it drops to 0.805. Almost all of that loss is one class: 16QAM is recognised 5.6 percent of the time, and it is read as 64QAM. The four questions on the right are the project: how large is the drop, what causes it, can it be removed, and where does an unseen modulation go.
+The contribution is the attribution method, not an accuracy number. The 0.999 to 0.805 drop is the starting measurement, on five shared classes, five seeds.</a:t>
             </a:r>
             <a:endParaRPr lang="en-US" dirty="0"/>
           </a:p>
@@ -3992,7 +3999,8 @@
           <a:p>
             <a:r>
               <a:rPr lang="en-US" dirty="0"/>
-              <a:t>Decided with Moshe on 16 September: new work goes on 2018 only. The 2016 results are not retracted.</a:t>
+              <a:t>The dataset is RadioML 2018.01A. 24 modulation classes, 1,024 I/Q samples per frame, 26 SNR levels from minus 20 to plus 30 dB, 4,096 frames per class and SNR. About 2.5 million frames. We decided last week to work on this one dataset only. The panel on the left shows the mean power spectrum of each class: every class shares the same spectral envelope, and that turns out to be the key to the failure.
+Decided with Moshe on 16 September: new work goes on 2018 only. The 2016 results are not retracted.</a:t>
             </a:r>
             <a:endParaRPr lang="en-US" dirty="0"/>
           </a:p>
@@ -4080,7 +4088,8 @@
           <a:p>
             <a:r>
               <a:rPr lang="en-US" dirty="0"/>
-              <a:t>The backbone is transcribed from a peer's reproduction and differs from the published ICRNNA in five places; it is not called 'the published architecture'. The faithful build is a separate file and does reproduce the paper.</a:t>
+              <a:t>Input: one frame, 2 by 1,024, normalised to unit power. Model: ICRNNA, a convolutional front end, a bidirectional LSTM and attention, 786 thousand parameters. Output: one of K classes. Protocol: 70-15-15 split stratified over every class and SNR; early stopping reads validation only, the test set is touched once. Three seeds per configuration. And one rule I want to state explicitly: a run counts only if its best epoch plus the patience fits under the ceiling. Otherwise it is a floor, not a measurement. Every result here passes that test.
+The backbone is transcribed from a peer's reproduction and differs from the published ICRNNA in five places; it is not called 'the published architecture'. The faithful build is a separate file and does reproduce the paper.</a:t>
             </a:r>
             <a:endParaRPr lang="en-US" dirty="0"/>
           </a:p>
@@ -4168,7 +4177,8 @@
           <a:p>
             <a:r>
               <a:rPr lang="en-US" dirty="0"/>
-              <a:t>Deep residual networks on the whole dataset are reported near 95% above 8 dB; this is 512 of 4096 frames per cell with a 786k recurrent model. Closing that gap is not the goal.</a:t>
+              <a:t>Before anything about domain shift: does the model classify at all. On 24 classes above 10 dB it is at 87.2 percent. On the four classes we agreed on, BPSK, QPSK, 16QAM, 64QAM, it is at 100 percent above 10 dB. The curve sits at chance below minus 12 dB and saturates from plus 8. This is not the contribution; it is the floor the rest stands on.
+Deep residual networks on the whole dataset are reported near 95% above 8 dB; this is 512 of 4096 frames per cell with a 786k recurrent model. Closing that gap is not the goal.</a:t>
             </a:r>
             <a:endParaRPr lang="en-US" dirty="0"/>
           </a:p>
@@ -4256,7 +4266,8 @@
           <a:p>
             <a:r>
               <a:rPr lang="en-US" dirty="0"/>
-              <a:t>This is the table asked for on 15 September. The same table on RML2016 (128-sample frames) still confuses the QAM pair 7–11% at high SNR; at 1,024 samples that confusion is gone. The frame is the difference.</a:t>
+              <a:t>This is the table you asked for. Rows are what we transmitted, columns are what the model decided. Every row is 10,164 decisions: 308 test frames per class and SNR, 11 SNR levels from 10 to 30 dB, three seeds. Each decision is a different frame, different symbols, different channel, different noise. 40,654 of 40,656 correct. The two errors are both 64QAM decided as 16QAM. All three seeds converged, peaks at epochs 46, 48 and 66 under a ceiling of 150.
+This is the table asked for on 15 September. The same table on RML2016 (128-sample frames) still confuses the QAM pair 7–11% at high SNR; at 1,024 samples that confusion is gone. The frame is the difference.</a:t>
             </a:r>
             <a:endParaRPr lang="en-US" dirty="0"/>
           </a:p>
@@ -4344,7 +4355,8 @@
           <a:p>
             <a:r>
               <a:rPr lang="en-US" dirty="0"/>
-              <a:t>924 decisions per row at each single level; a 1% cell is nine frames. Both matrices are from the converged run.</a:t>
+              <a:t>A perfect table at high SNR says nothing, so here is the same table lower down. At 0 dB: BPSK and QPSK are still perfect. 16QAM and 64QAM are a coin flip against each other, 519 against 396 and 349 against 569. Nine hundred twenty-four decisions per row. There are two thresholds: PSK versus QAM closes between minus 4 and 0 dB, which QAM closes between 0 and plus 6. Below the first threshold the classes do not scatter, they sink: at minus 8 dB, 16QAM is read as QPSK 68 percent of the time.
+924 decisions per row at each single level; a 1% cell is nine frames. Both matrices are from the converged run.</a:t>
             </a:r>
             <a:endParaRPr lang="en-US" dirty="0"/>
           </a:p>
@@ -4432,7 +4444,8 @@
           <a:p>
             <a:r>
               <a:rPr lang="en-US" dirty="0"/>
-              <a:t>Stopping epochs by method: none 51/41/48/36/38, augmentation 89/48/83/65/82, whitening 26/26/33/43/25, both 66/37/53/37/50. Whitening converges about 2.4× faster than augmentation — it removes a nuisance dimension, augmentation adds one.</a:t>
+              <a:t>Now the domain gap. Five shared classes, five seeds each, all converged. In-domain never moves: 0.999 or 1.000 in every column. Cross-domain: 0.805 with nothing, 0.807 with the standard augmentation set from the literature, rotation, conjugate flip and additive noise, so plus 0.002. With spectral whitening, 0.989. Whitening plus augmentation, 0.995, but that plus 0.006 is one standard deviation, so I do not call it a difference. Each cross-domain number is 110,000 decisions: 2,000 per SNR level, 11 levels, 5 seeds.
+Stopping epochs by method: none 51/41/48/36/38, augmentation 89/48/83/65/82, whitening 26/26/33/43/25, both 66/37/53/37/50. Whitening converges about 2.4× faster than augmentation — it removes a nuisance dimension, augmentation adds one.</a:t>
             </a:r>
             <a:endParaRPr lang="en-US" dirty="0"/>
           </a:p>
@@ -4520,7 +4533,8 @@
           <a:p>
             <a:r>
               <a:rPr lang="en-US" dirty="0"/>
-              <a:t>The working story for most of the project was shortcut learning — the model reads modulation order off the envelope. Two experiments killed it: handing 16QAM frames a 64QAM envelope left the prediction at 16QAM. The envelope does not carry the class; removing it still helps. That is stated as unresolved.</a:t>
+              <a:t>What causes it. Four explanations were tested and refuted: occupied bandwidth, constellation density, symbol timing, channel impairments. Each was matched or removed and the prediction did not move. The one thing that moves it is an intervention: take a failing frame, keep its phase spectrum exactly, substitute only the magnitude spectrum of the training domain. The prediction follows the magnitude spectrum. That is a causal claim, because we changed the signal, not the representation. The cause is the transmitter's spectral envelope, mainly the pulse-shaping roll-off.
+The working story for most of the project was shortcut learning — the model reads modulation order off the envelope. Two experiments killed it: handing 16QAM frames a 64QAM envelope left the prediction at 16QAM. The envelope does not carry the class; removing it still helps. That is stated as unresolved.</a:t>
             </a:r>
             <a:endParaRPr lang="en-US" dirty="0"/>
           </a:p>
@@ -5413,7 +5427,7 @@
       </p:sp>
       <p:sp>
         <p:nvSpPr>
-          <p:cNvPr id="11" name="Text 8"/>
+          <p:cNvPr id="12" name="Text 8"/>
           <p:cNvSpPr txBox="1"/>
           <p:nvPr/>
         </p:nvSpPr>
@@ -8333,7 +8347,7 @@
       </p:sp>
       <p:sp>
         <p:nvSpPr>
-          <p:cNvPr id="15" name="Text 11"/>
+          <p:cNvPr id="16" name="Text 11"/>
           <p:cNvSpPr txBox="1"/>
           <p:nvPr/>
         </p:nvSpPr>
@@ -8989,7 +9003,7 @@
       </p:sp>
       <p:sp>
         <p:nvSpPr>
-          <p:cNvPr id="19" name="Text 17"/>
+          <p:cNvPr id="20" name="Text 17"/>
           <p:cNvSpPr txBox="1"/>
           <p:nvPr/>
         </p:nvSpPr>
@@ -9775,7 +9789,7 @@
       </p:sp>
       <p:sp>
         <p:nvSpPr>
-          <p:cNvPr id="23" name="Text 21"/>
+          <p:cNvPr id="24" name="Text 21"/>
           <p:cNvSpPr txBox="1"/>
           <p:nvPr/>
         </p:nvSpPr>
@@ -10158,7 +10172,7 @@
       </p:sp>
       <p:sp>
         <p:nvSpPr>
-          <p:cNvPr id="10" name="Text 8"/>
+          <p:cNvPr id="11" name="Text 8"/>
           <p:cNvSpPr txBox="1"/>
           <p:nvPr/>
         </p:nvSpPr>
@@ -11019,7 +11033,7 @@
       </p:sp>
       <p:sp>
         <p:nvSpPr>
-          <p:cNvPr id="24" name="Text 22"/>
+          <p:cNvPr id="25" name="Text 22"/>
           <p:cNvSpPr txBox="1"/>
           <p:nvPr/>
         </p:nvSpPr>
@@ -11582,7 +11596,7 @@
       </p:sp>
       <p:sp>
         <p:nvSpPr>
-          <p:cNvPr id="15" name="Text 12"/>
+          <p:cNvPr id="16" name="Text 12"/>
           <p:cNvSpPr txBox="1"/>
           <p:nvPr/>
         </p:nvSpPr>
@@ -12487,7 +12501,7 @@
       </p:sp>
       <p:sp>
         <p:nvSpPr>
-          <p:cNvPr id="21" name="Text 19"/>
+          <p:cNvPr id="22" name="Text 19"/>
           <p:cNvSpPr txBox="1"/>
           <p:nvPr/>
         </p:nvSpPr>
@@ -12847,7 +12861,7 @@
       </p:sp>
       <p:sp>
         <p:nvSpPr>
-          <p:cNvPr id="10" name="Text 7"/>
+          <p:cNvPr id="11" name="Text 7"/>
           <p:cNvSpPr txBox="1"/>
           <p:nvPr/>
         </p:nvSpPr>
@@ -15287,7 +15301,7 @@
       </p:sp>
       <p:sp>
         <p:nvSpPr>
-          <p:cNvPr id="12" name="Text 7"/>
+          <p:cNvPr id="13" name="Text 7"/>
           <p:cNvSpPr txBox="1"/>
           <p:nvPr/>
         </p:nvSpPr>
@@ -17702,7 +17716,7 @@
       </p:sp>
       <p:sp>
         <p:nvSpPr>
-          <p:cNvPr id="10" name="Text 6"/>
+          <p:cNvPr id="11" name="Text 6"/>
           <p:cNvSpPr txBox="1"/>
           <p:nvPr/>
         </p:nvSpPr>
@@ -18812,7 +18826,7 @@
       </p:sp>
       <p:sp>
         <p:nvSpPr>
-          <p:cNvPr id="9" name="Text 5"/>
+          <p:cNvPr id="10" name="Text 5"/>
           <p:cNvSpPr txBox="1"/>
           <p:nvPr/>
         </p:nvSpPr>
@@ -19815,7 +19829,7 @@
       </p:sp>
       <p:sp>
         <p:nvSpPr>
-          <p:cNvPr id="28" name="Text 26"/>
+          <p:cNvPr id="29" name="Text 26"/>
           <p:cNvSpPr txBox="1"/>
           <p:nvPr/>
         </p:nvSpPr>

</xml_diff>

<commit_message>
Slide 4: the impairment in RadioML 2018 is deliberate
Every frame draws its own channel (roll-off, carrier and clock offsets,
Rayleigh fading) and the 24-class set applies impairments beyond what
its high-order modes would see in practice, per the dataset paper. Now
on the slide and in the script, not only in the notes.

Co-Authored-By: Claude Fable 5.1 <noreply@anthropic.com>
Claude-Session: https://claude.ai/code/session_01UiTC1BeuJK5BZLbarMcqjw
</commit_message>
<xml_diff>
--- a/deck/amc_progress.pptx
+++ b/deck/amc_progress.pptx
@@ -5024,7 +5024,7 @@
           <a:p>
             <a:r>
               <a:rPr lang="en-US" dirty="0"/>
-              <a:t>One more thing about the dataset, because it decides which four classes we use. The paper that made it reports which classes stay hard even at high SNR: the high-order QAM block, 64, 128 and 256, the 16 and 32 PSK pair, and the AM pairs with and without carrier. Their explanation is that at 1,024 samples there is not enough information to separate them, by any method, and that the AM message content is a small voice corpus. Our own 24-class run reproduces exactly that: the six classes under 80 percent are those, and everything else is above 79. None of the six is in the four-class table. And the alternative dataset, 2016, is worse on exactly this table: its frames are 128 samples, so 16QAM and 64QAM confuse each other 8 to 9 percent even at high SNR, and its WBFM class is broken. So the four classes and the dataset are chosen together.
+              <a:t>One more thing about the dataset, because it decides which four classes we use. The impairment in RadioML 2018 is deliberate. Every frame draws its own random channel: a pulse-shaping roll-off between 0.1 and 0.4, carrier and clock offsets, Rayleigh fading. And for the 24-class set the authors say they apply impairments beyond what one would expect for the high-order modes, in a 1,024-sample window. So some classes stay hard even at high SNR: the high-order QAM block, 64, 128 and 256, the 16 and 32 PSK pair, and the AM pairs with and without carrier. Their explanation is that there is not enough information to separate them, by any method, and that the AM message content is a small voice corpus. Our own 24-class run reproduces exactly that: the six classes under 80 percent are those, and everything else is above 79. None of the six is in the four-class table. And the alternative dataset, 2016, is worse on exactly this table: its frames are 128 samples, so 16QAM and 64QAM confuse each other 8 to 9 percent even at high SNR, and its WBFM class is broken. So the four classes and the dataset are chosen together.
 O'Shea, Roy &amp; Clancy, IEEE JSTSP 12(1) 2018, Figs. 12–15 and 17. The paper also deliberately applies impairments 'beyond that which one would expect' to the 24-class set. Their synthetic-to-over-the-air drop is about 7 points and lands on the same blocks.</a:t>
             </a:r>
             <a:endParaRPr lang="en-US" dirty="0"/>
@@ -20161,11 +20161,11 @@
         <p:spPr>
           <a:xfrm>
             <a:off x="7498080" y="1554480"/>
-            <a:ext cx="4160520" cy="2148840"/>
+            <a:ext cx="4160520" cy="2560320"/>
           </a:xfrm>
           <a:prstGeom prst="roundRect">
             <a:avLst>
-              <a:gd name="adj" fmla="val 3404"/>
+              <a:gd name="adj" fmla="val 2857"/>
             </a:avLst>
           </a:prstGeom>
           <a:solidFill>
@@ -20227,7 +20227,7 @@
         <p:spPr>
           <a:xfrm>
             <a:off x="7680960" y="2011680"/>
-            <a:ext cx="3840480" cy="1645920"/>
+            <a:ext cx="3840480" cy="2011680"/>
           </a:xfrm>
           <a:prstGeom prst="rect">
             <a:avLst/>
@@ -20247,7 +20247,7 @@
               <a:buChar char="•"/>
             </a:pPr>
             <a:r>
-              <a:rPr lang="en-US" sz="1050" dirty="0">
+              <a:rPr lang="en-US" sz="1000" dirty="0">
                 <a:solidFill>
                   <a:srgbClr val="13315C"/>
                 </a:solidFill>
@@ -20255,9 +20255,9 @@
                 <a:ea typeface="Calibri" pitchFamily="34" charset="-122"/>
                 <a:cs typeface="Calibri" pitchFamily="34" charset="-120"/>
               </a:rPr>
-              <a:t>64 / 128 / 256QAM and 16 / 32PSK: at 1,024 samples "significant error is expected simply due to lack of information and similar symbol structure", by any method</a:t>
+              <a:t>The impairment is deliberate: every frame draws its own channel — roll-off U(0.1, 0.4), carrier and clock offsets, Rayleigh fading — and the 24-class set applies impairments "beyond that which one would expect" for its high-order modes, in a 1,024-sample window</a:t>
             </a:r>
-            <a:endParaRPr lang="en-US" sz="1050" dirty="0"/>
+            <a:endParaRPr lang="en-US" sz="1000" dirty="0"/>
           </a:p>
           <a:p>
             <a:pPr marL="342900" indent="-342900">
@@ -20268,7 +20268,7 @@
               <a:buChar char="•"/>
             </a:pPr>
             <a:r>
-              <a:rPr lang="en-US" sz="1050" dirty="0">
+              <a:rPr lang="en-US" sz="1000" dirty="0">
                 <a:solidFill>
                   <a:srgbClr val="13315C"/>
                 </a:solidFill>
@@ -20276,9 +20276,9 @@
                 <a:ea typeface="Calibri" pitchFamily="34" charset="-122"/>
                 <a:cs typeface="Calibri" pitchFamily="34" charset="-120"/>
               </a:rPr>
-              <a:t>AM with-carrier vs suppressed-carrier: the analog message is a small voice corpus</a:t>
+              <a:t>64 / 128 / 256QAM and 16 / 32PSK: "significant error is expected simply due to lack of information and similar symbol structure", by any method</a:t>
             </a:r>
-            <a:endParaRPr lang="en-US" sz="1050" dirty="0"/>
+            <a:endParaRPr lang="en-US" sz="1000" dirty="0"/>
           </a:p>
           <a:p>
             <a:pPr marL="342900" indent="-342900">
@@ -20289,7 +20289,28 @@
               <a:buChar char="•"/>
             </a:pPr>
             <a:r>
-              <a:rPr lang="en-US" sz="1050" dirty="0">
+              <a:rPr lang="en-US" sz="1000" dirty="0">
+                <a:solidFill>
+                  <a:srgbClr val="13315C"/>
+                </a:solidFill>
+                <a:latin typeface="Calibri" pitchFamily="34" charset="0"/>
+                <a:ea typeface="Calibri" pitchFamily="34" charset="-122"/>
+                <a:cs typeface="Calibri" pitchFamily="34" charset="-120"/>
+              </a:rPr>
+              <a:t>AM with-carrier vs suppressed-carrier: the analog message is a small voice corpus</a:t>
+            </a:r>
+            <a:endParaRPr lang="en-US" sz="1000" dirty="0"/>
+          </a:p>
+          <a:p>
+            <a:pPr marL="342900" indent="-342900">
+              <a:spcAft>
+                <a:spcPts val="600"/>
+              </a:spcAft>
+              <a:buSzPct val="100000"/>
+              <a:buChar char="•"/>
+            </a:pPr>
+            <a:r>
+              <a:rPr lang="en-US" sz="1000" dirty="0">
                 <a:solidFill>
                   <a:srgbClr val="13315C"/>
                 </a:solidFill>
@@ -20299,7 +20320,7 @@
               </a:rPr>
               <a:t>Our six classes under 80%: AM-DSB-WC, 64QAM, 256QAM, AM-SSB-WC, 128QAM, 16APSK, AM-SSB-SC. Same blocks.</a:t>
             </a:r>
-            <a:endParaRPr lang="en-US" sz="1050" dirty="0"/>
+            <a:endParaRPr lang="en-US" sz="1000" dirty="0"/>
           </a:p>
         </p:txBody>
       </p:sp>
@@ -20311,12 +20332,12 @@
         </p:nvSpPr>
         <p:spPr>
           <a:xfrm>
-            <a:off x="7498080" y="3840480"/>
-            <a:ext cx="4160520" cy="2286000"/>
+            <a:off x="7498080" y="4251960"/>
+            <a:ext cx="4160520" cy="1965960"/>
           </a:xfrm>
           <a:prstGeom prst="roundRect">
             <a:avLst>
-              <a:gd name="adj" fmla="val 3200"/>
+              <a:gd name="adj" fmla="val 3721"/>
             </a:avLst>
           </a:prstGeom>
           <a:solidFill>
@@ -20338,7 +20359,7 @@
         </p:nvSpPr>
         <p:spPr>
           <a:xfrm>
-            <a:off x="7680960" y="3931920"/>
+            <a:off x="7680960" y="4343400"/>
             <a:ext cx="3840480" cy="320040"/>
           </a:xfrm>
           <a:prstGeom prst="rect">
@@ -20377,8 +20398,8 @@
         </p:nvSpPr>
         <p:spPr>
           <a:xfrm>
-            <a:off x="7680960" y="4297680"/>
-            <a:ext cx="3840480" cy="1783080"/>
+            <a:off x="7680960" y="4709160"/>
+            <a:ext cx="3840480" cy="1463040"/>
           </a:xfrm>
           <a:prstGeom prst="rect">
             <a:avLst/>
@@ -20398,7 +20419,7 @@
               <a:buChar char="•"/>
             </a:pPr>
             <a:r>
-              <a:rPr lang="en-US" sz="1050" dirty="0">
+              <a:rPr lang="en-US" sz="1000" dirty="0">
                 <a:solidFill>
                   <a:srgbClr val="13315C"/>
                 </a:solidFill>
@@ -20408,7 +20429,7 @@
               </a:rPr>
               <a:t>128-sample frames: 16QAM and 64QAM confuse each other even above 10 dB — QAM16 recall 91.8%, QAM64 90.8%; on 2018 both are 100.0%</a:t>
             </a:r>
-            <a:endParaRPr lang="en-US" sz="1050" dirty="0"/>
+            <a:endParaRPr lang="en-US" sz="1000" dirty="0"/>
           </a:p>
           <a:p>
             <a:pPr marL="342900" indent="-342900">
@@ -20419,7 +20440,7 @@
               <a:buChar char="•"/>
             </a:pPr>
             <a:r>
-              <a:rPr lang="en-US" sz="1050" dirty="0">
+              <a:rPr lang="en-US" sz="1000" dirty="0">
                 <a:solidFill>
                   <a:srgbClr val="13315C"/>
                 </a:solidFill>
@@ -20429,7 +20450,7 @@
               </a:rPr>
               <a:t>WBFM at 39.6%, drained into AM-DSB: a known defect of that file</a:t>
             </a:r>
-            <a:endParaRPr lang="en-US" sz="1050" dirty="0"/>
+            <a:endParaRPr lang="en-US" sz="1000" dirty="0"/>
           </a:p>
           <a:p>
             <a:pPr marL="342900" indent="-342900">
@@ -20440,7 +20461,7 @@
               <a:buChar char="•"/>
             </a:pPr>
             <a:r>
-              <a:rPr lang="en-US" sz="1050" dirty="0">
+              <a:rPr lang="en-US" sz="1000" dirty="0">
                 <a:solidFill>
                   <a:srgbClr val="13315C"/>
                 </a:solidFill>
@@ -20450,7 +20471,7 @@
               </a:rPr>
               <a:t>Every degraded 2018 class is outside the four-class table; the 2016 defects are inside it</a:t>
             </a:r>
-            <a:endParaRPr lang="en-US" sz="1050" dirty="0"/>
+            <a:endParaRPr lang="en-US" sz="1000" dirty="0"/>
           </a:p>
         </p:txBody>
       </p:sp>

</xml_diff>

<commit_message>
Decision table slide: zero errors from +14 dB, counted
33,264 decisions across nine SNR levels, all four classes, all three
seeds, no error. The two errors above 10 dB sit at 10 and 12 dB. This is
the 'establish it in the simulated environment first' that was asked
for, stated as a count on the slide and in the script.

Co-Authored-By: Claude Fable 5.1 <noreply@anthropic.com>
Claude-Session: https://claude.ai/code/session_01UiTC1BeuJK5BZLbarMcqjw
</commit_message>
<xml_diff>
--- a/deck/amc_progress.pptx
+++ b/deck/amc_progress.pptx
@@ -5291,7 +5291,7 @@
           <a:p>
             <a:r>
               <a:rPr lang="en-US" dirty="0"/>
-              <a:t>This is the table you asked for. Rows are what we transmitted, columns are what the model decided. Every row is 10,164 decisions: 308 test frames per class and SNR, 11 SNR levels from 10 to 30 dB, three seeds. Each decision is a different frame, different symbols, different channel, different noise. 40,654 of 40,656 correct. The two errors are both 64QAM decided as 16QAM. All three seeds converged, peaks at epochs 46, 48 and 66 under a ceiling of 150.
+              <a:t>This is the table you asked for. Rows are what we transmitted, columns are what the model decided. Every row is 10,164 decisions: 308 test frames per class and SNR, 11 SNR levels from 10 to 30 dB, three seeds. Each decision is a different frame, different symbols, different channel, different noise. 40,654 of 40,656 correct. The two errors are both 64QAM decided as 16QAM, at 10 and 12 dB. From 14 dB up there are none: 33,264 decisions, zero errors, all four classes, all three seeds. That is the 100 percent you asked us to establish in the simulated environment before moving on. All three seeds converged, peaks at epochs 46, 48 and 66 under a ceiling of 150.
 This is the table asked for on 15 September. The same table on RML2016 (128-sample frames) still confuses the QAM pair 7–11% at high SNR; at 1,024 samples that confusion is gone. The frame is the difference.</a:t>
             </a:r>
             <a:endParaRPr lang="en-US" dirty="0"/>
@@ -24077,7 +24077,85 @@
       </p:sp>
       <p:sp>
         <p:nvSpPr>
-          <p:cNvPr id="9" name="Shape 4"/>
+          <p:cNvPr id="9" name="Text 4"/>
+          <p:cNvSpPr txBox="1"/>
+          <p:nvPr/>
+        </p:nvSpPr>
+        <p:spPr>
+          <a:xfrm>
+            <a:off x="548640" y="4069080"/>
+            <a:ext cx="6949440" cy="868680"/>
+          </a:xfrm>
+          <a:prstGeom prst="rect">
+            <a:avLst/>
+          </a:prstGeom>
+          <a:noFill/>
+          <a:ln/>
+        </p:spPr>
+        <p:txBody>
+          <a:bodyPr wrap="square" lIns="0" tIns="0" rIns="0" bIns="0" rtlCol="0" anchor="b"/>
+          <a:lstStyle/>
+          <a:p>
+            <a:pPr indent="0" marL="0">
+              <a:buNone/>
+            </a:pPr>
+            <a:r>
+              <a:rPr lang="en-US" sz="3000" b="1" dirty="0">
+                <a:solidFill>
+                  <a:srgbClr val="1B998B"/>
+                </a:solidFill>
+                <a:latin typeface="Cambria" pitchFamily="34" charset="0"/>
+                <a:ea typeface="Cambria" pitchFamily="34" charset="-122"/>
+                <a:cs typeface="Cambria" pitchFamily="34" charset="-120"/>
+              </a:rPr>
+              <a:t>0 errors in 33,264 decisions</a:t>
+            </a:r>
+            <a:endParaRPr lang="en-US" sz="3000" dirty="0"/>
+          </a:p>
+        </p:txBody>
+      </p:sp>
+      <p:sp>
+        <p:nvSpPr>
+          <p:cNvPr id="10" name="Text 5"/>
+          <p:cNvSpPr txBox="1"/>
+          <p:nvPr/>
+        </p:nvSpPr>
+        <p:spPr>
+          <a:xfrm>
+            <a:off x="548640" y="4956048"/>
+            <a:ext cx="6949440" cy="502920"/>
+          </a:xfrm>
+          <a:prstGeom prst="rect">
+            <a:avLst/>
+          </a:prstGeom>
+          <a:noFill/>
+          <a:ln/>
+        </p:spPr>
+        <p:txBody>
+          <a:bodyPr wrap="square" lIns="0" tIns="0" rIns="0" bIns="0" rtlCol="0" anchor="t"/>
+          <a:lstStyle/>
+          <a:p>
+            <a:pPr indent="0" marL="0">
+              <a:buNone/>
+            </a:pPr>
+            <a:r>
+              <a:rPr lang="en-US" sz="1250" dirty="0">
+                <a:solidFill>
+                  <a:srgbClr val="5C7A99"/>
+                </a:solidFill>
+                <a:latin typeface="Calibri" pitchFamily="34" charset="0"/>
+                <a:ea typeface="Calibri" pitchFamily="34" charset="-122"/>
+                <a:cs typeface="Calibri" pitchFamily="34" charset="-120"/>
+              </a:rPr>
+              <a:t>from +14 dB up: 9 SNR levels, all four classes, all three seeds — the hypothesis held in the simulated environment, as asked</a:t>
+            </a:r>
+            <a:endParaRPr lang="en-US" sz="1250" dirty="0"/>
+          </a:p>
+        </p:txBody>
+      </p:sp>
+      <p:sp>
+        <p:nvSpPr>
+          <p:cNvPr id="11" name="Shape 6"/>
           <p:cNvSpPr/>
           <p:nvPr/>
         </p:nvSpPr>
@@ -24104,7 +24182,7 @@
       </p:sp>
       <p:sp>
         <p:nvSpPr>
-          <p:cNvPr id="10" name="Text 5"/>
+          <p:cNvPr id="12" name="Text 7"/>
           <p:cNvSpPr txBox="1"/>
           <p:nvPr/>
         </p:nvSpPr>
@@ -24143,7 +24221,7 @@
       </p:sp>
       <p:sp>
         <p:nvSpPr>
-          <p:cNvPr id="11" name="Text 6"/>
+          <p:cNvPr id="13" name="Text 8"/>
           <p:cNvSpPr txBox="1"/>
           <p:nvPr/>
         </p:nvSpPr>
@@ -24182,7 +24260,7 @@
       </p:sp>
       <p:sp>
         <p:nvSpPr>
-          <p:cNvPr id="13" name="Text 7"/>
+          <p:cNvPr id="15" name="Text 9"/>
           <p:cNvSpPr txBox="1"/>
           <p:nvPr/>
         </p:nvSpPr>

</xml_diff>

<commit_message>
Deck: define the second transmitter; one-sentence version of every slide
Slide 2 now states what differs between the training and test
transmitters: RadioML draws a roll-off per frame and adds offsets and
multipath, our generator fixes the roll-off at 0.35 and adds only noise,
so the test domain is the cleaner one. The script gains a one-sentence
version per slide for when time is short.

Co-Authored-By: Claude Fable 5.1 <noreply@anthropic.com>
Claude-Session: https://claude.ai/code/session_01UiTC1BeuJK5BZLbarMcqjw
</commit_message>
<xml_diff>
--- a/deck/amc_progress.pptx
+++ b/deck/amc_progress.pptx
@@ -4846,7 +4846,7 @@
           <a:p>
             <a:r>
               <a:rPr lang="en-US" dirty="0"/>
-              <a:t>The setup. Train on RadioML. Then test on I/Q from a different transmitter model: same five modulations, same SNRs, same sample rate. In-domain the model is at 0.999. On the other transmitter it drops to 0.805. Almost all of that loss is one class: 16QAM is recognised 5.6 percent of the time, and it is read as 64QAM. The four questions on the right are the project: how large is the drop, what causes it, can it be removed, and where does an unseen modulation go.
+              <a:t>The setup. Train on RadioML. Then test on I/Q from a second transmitter: our own baseband generator, same five modulations, same SNR grid, same 1,024-sample frames. What differs is in the small table: RadioML draws a pulse-shaping roll-off per frame between 0.1 and 0.4 and adds carrier, clock and timing offsets and multipath; our generator uses a fixed roll-off of 0.35 and nothing but noise. So the test domain is the cleaner one. In-domain the model is at 0.999. On the other transmitter it drops to 0.805. Almost all of that loss is one class: 16QAM is recognised 5.6 percent of the time, and it is read as 64QAM. The four questions on the right are the project: how large is the drop, what causes it, can it be removed, and where does an unseen modulation go.
 The contribution is the attribution method, not an accuracy number. The 0.999 to 0.805 drop is the starting measurement, on five shared classes, five seeds.</a:t>
             </a:r>
             <a:endParaRPr lang="en-US" dirty="0"/>
@@ -18640,11 +18640,11 @@
         <p:spPr>
           <a:xfrm>
             <a:off x="548640" y="1737360"/>
-            <a:ext cx="5486400" cy="4206240"/>
+            <a:ext cx="5486400" cy="4434840"/>
           </a:xfrm>
           <a:prstGeom prst="roundRect">
             <a:avLst>
-              <a:gd name="adj" fmla="val 1739"/>
+              <a:gd name="adj" fmla="val 1649"/>
             </a:avLst>
           </a:prstGeom>
           <a:solidFill>
@@ -18667,7 +18667,7 @@
         <p:spPr>
           <a:xfrm>
             <a:off x="822960" y="1874520"/>
-            <a:ext cx="4937760" cy="1097280"/>
+            <a:ext cx="4937760" cy="868680"/>
           </a:xfrm>
           <a:prstGeom prst="rect">
             <a:avLst/>
@@ -18683,7 +18683,7 @@
               <a:buNone/>
             </a:pPr>
             <a:r>
-              <a:rPr lang="en-US" sz="1500" dirty="0">
+              <a:rPr lang="en-US" sz="1400" dirty="0">
                 <a:solidFill>
                   <a:srgbClr val="13315C"/>
                 </a:solidFill>
@@ -18691,9 +18691,9 @@
                 <a:ea typeface="Calibri" pitchFamily="34" charset="-122"/>
                 <a:cs typeface="Calibri" pitchFamily="34" charset="-120"/>
               </a:rPr>
-              <a:t>Train on RadioML. Test on I/Q generated by an independent transmitter model. Same five modulations, same SNRs, same sample rate.</a:t>
+              <a:t>Train on RadioML. Test on I/Q from our own transmitter model: same five modulations, same SNR grid, same 1,024-sample frames at 8 samples per symbol.</a:t>
             </a:r>
-            <a:endParaRPr lang="en-US" sz="1500" dirty="0"/>
+            <a:endParaRPr lang="en-US" sz="1400" dirty="0"/>
           </a:p>
         </p:txBody>
       </p:sp>
@@ -18705,7 +18705,7 @@
         </p:nvSpPr>
         <p:spPr>
           <a:xfrm>
-            <a:off x="822960" y="3017520"/>
+            <a:off x="822960" y="2743200"/>
             <a:ext cx="2286000" cy="868680"/>
           </a:xfrm>
           <a:prstGeom prst="rect">
@@ -18722,7 +18722,7 @@
               <a:buNone/>
             </a:pPr>
             <a:r>
-              <a:rPr lang="en-US" sz="4400" b="1" dirty="0">
+              <a:rPr lang="en-US" sz="4000" b="1" dirty="0">
                 <a:solidFill>
                   <a:srgbClr val="1B998B"/>
                 </a:solidFill>
@@ -18732,7 +18732,7 @@
               </a:rPr>
               <a:t>0.999</a:t>
             </a:r>
-            <a:endParaRPr lang="en-US" sz="4400" dirty="0"/>
+            <a:endParaRPr lang="en-US" sz="4000" dirty="0"/>
           </a:p>
         </p:txBody>
       </p:sp>
@@ -18744,7 +18744,7 @@
         </p:nvSpPr>
         <p:spPr>
           <a:xfrm>
-            <a:off x="822960" y="3904488"/>
+            <a:off x="822960" y="3630168"/>
             <a:ext cx="2286000" cy="502920"/>
           </a:xfrm>
           <a:prstGeom prst="rect">
@@ -18783,7 +18783,7 @@
         </p:nvSpPr>
         <p:spPr>
           <a:xfrm>
-            <a:off x="3291840" y="3017520"/>
+            <a:off x="3291840" y="2743200"/>
             <a:ext cx="2286000" cy="868680"/>
           </a:xfrm>
           <a:prstGeom prst="rect">
@@ -18800,7 +18800,7 @@
               <a:buNone/>
             </a:pPr>
             <a:r>
-              <a:rPr lang="en-US" sz="4400" b="1" dirty="0">
+              <a:rPr lang="en-US" sz="4000" b="1" dirty="0">
                 <a:solidFill>
                   <a:srgbClr val="C0392B"/>
                 </a:solidFill>
@@ -18810,7 +18810,7 @@
               </a:rPr>
               <a:t>0.805</a:t>
             </a:r>
-            <a:endParaRPr lang="en-US" sz="4400" dirty="0"/>
+            <a:endParaRPr lang="en-US" sz="4000" dirty="0"/>
           </a:p>
         </p:txBody>
       </p:sp>
@@ -18822,7 +18822,7 @@
         </p:nvSpPr>
         <p:spPr>
           <a:xfrm>
-            <a:off x="3291840" y="3904488"/>
+            <a:off x="3291840" y="3630168"/>
             <a:ext cx="2286000" cy="502920"/>
           </a:xfrm>
           <a:prstGeom prst="rect">
@@ -18861,8 +18861,8 @@
         </p:nvSpPr>
         <p:spPr>
           <a:xfrm>
-            <a:off x="822960" y="4754880"/>
-            <a:ext cx="4937760" cy="457200"/>
+            <a:off x="822960" y="4343400"/>
+            <a:ext cx="4937760" cy="365760"/>
           </a:xfrm>
           <a:prstGeom prst="rect">
             <a:avLst/>
@@ -18878,7 +18878,7 @@
               <a:buNone/>
             </a:pPr>
             <a:r>
-              <a:rPr lang="en-US" sz="1400" b="1" dirty="0">
+              <a:rPr lang="en-US" sz="1300" b="1" dirty="0">
                 <a:solidFill>
                   <a:srgbClr val="13315C"/>
                 </a:solidFill>
@@ -18888,13 +18888,830 @@
               </a:rPr>
               <a:t>16QAM alone: 0.056 — it is read as 64QAM</a:t>
             </a:r>
-            <a:endParaRPr lang="en-US" sz="1400" dirty="0"/>
+            <a:endParaRPr lang="en-US" sz="1300" dirty="0"/>
           </a:p>
         </p:txBody>
       </p:sp>
+      <p:graphicFrame>
+        <p:nvGraphicFramePr>
+          <p:cNvPr id="3" name="Table 0"/>
+          <p:cNvGraphicFramePr>
+            <a:graphicFrameLocks noGrp="1"/>
+          </p:cNvGraphicFramePr>
+          <p:nvPr>
+            <p:extLst>
+              <p:ext uri="{D42A27DB-BD31-4B8C-83A1-F6EECF244321}">
+                <p14:modId xmlns:p14="http://schemas.microsoft.com/office/powerpoint/2010/main" val="1579011935"/>
+              </p:ext>
+            </p:extLst>
+          </p:nvPr>
+        </p:nvGraphicFramePr>
+        <p:xfrm>
+          <a:off x="822960" y="4800600"/>
+          <a:ext cx="4937760" cy="914400"/>
+        </p:xfrm>
+        <a:graphic>
+          <a:graphicData uri="http://schemas.openxmlformats.org/drawingml/2006/table">
+            <a:tbl>
+              <a:tblPr/>
+              <a:tblGrid>
+                <a:gridCol w="960120"/>
+                <a:gridCol w="2103120"/>
+                <a:gridCol w="1874520"/>
+              </a:tblGrid>
+              <a:tr h="274320">
+                <a:tc>
+                  <a:txBody>
+                    <a:bodyPr/>
+                    <a:lstStyle/>
+                    <a:p>
+                      <a:pPr indent="0" marL="0">
+                        <a:buNone/>
+                      </a:pPr>
+                      <a:endParaRPr lang="en-US" sz="900" dirty="0">
+                        <a:latin typeface="Calibri" charset="0"/>
+                        <a:ea typeface="Calibri" charset="0"/>
+                        <a:cs typeface="Calibri" charset="0"/>
+                      </a:endParaRPr>
+                    </a:p>
+                  </a:txBody>
+                  <a:tcPr marL="91440" marR="91440" marT="45720" marB="45720">
+                    <a:lnL w="6350" cap="flat" cmpd="sng" algn="ctr">
+                      <a:solidFill>
+                        <a:srgbClr val="D5DDE5"/>
+                      </a:solidFill>
+                      <a:prstDash val="solid"/>
+                      <a:round/>
+                      <a:headEnd type="none" w="med" len="med"/>
+                      <a:tailEnd type="none" w="med" len="med"/>
+                    </a:lnL>
+                    <a:lnR w="6350" cap="flat" cmpd="sng" algn="ctr">
+                      <a:solidFill>
+                        <a:srgbClr val="D5DDE5"/>
+                      </a:solidFill>
+                      <a:prstDash val="solid"/>
+                      <a:round/>
+                      <a:headEnd type="none" w="med" len="med"/>
+                      <a:tailEnd type="none" w="med" len="med"/>
+                    </a:lnR>
+                    <a:lnT w="6350" cap="flat" cmpd="sng" algn="ctr">
+                      <a:solidFill>
+                        <a:srgbClr val="D5DDE5"/>
+                      </a:solidFill>
+                      <a:prstDash val="solid"/>
+                      <a:round/>
+                      <a:headEnd type="none" w="med" len="med"/>
+                      <a:tailEnd type="none" w="med" len="med"/>
+                    </a:lnT>
+                    <a:lnB w="6350" cap="flat" cmpd="sng" algn="ctr">
+                      <a:solidFill>
+                        <a:srgbClr val="D5DDE5"/>
+                      </a:solidFill>
+                      <a:prstDash val="solid"/>
+                      <a:round/>
+                      <a:headEnd type="none" w="med" len="med"/>
+                      <a:tailEnd type="none" w="med" len="med"/>
+                    </a:lnB>
+                    <a:solidFill>
+                      <a:srgbClr val="DCE6F0"/>
+                    </a:solidFill>
+                  </a:tcPr>
+                </a:tc>
+                <a:tc>
+                  <a:txBody>
+                    <a:bodyPr/>
+                    <a:lstStyle/>
+                    <a:p>
+                      <a:pPr indent="0" marL="0">
+                        <a:buNone/>
+                      </a:pPr>
+                      <a:r>
+                        <a:rPr lang="en-US" sz="900" b="1" dirty="0">
+                          <a:solidFill>
+                            <a:srgbClr val="13315C"/>
+                          </a:solidFill>
+                          <a:latin typeface="Calibri" pitchFamily="34" charset="0"/>
+                          <a:ea typeface="Calibri" pitchFamily="34" charset="-122"/>
+                          <a:cs typeface="Calibri" pitchFamily="34" charset="-120"/>
+                        </a:rPr>
+                        <a:t>RadioML 2018 — trained on</a:t>
+                      </a:r>
+                      <a:endParaRPr lang="en-US" sz="900" dirty="0">
+                        <a:latin typeface="Calibri" charset="0"/>
+                        <a:ea typeface="Calibri" charset="0"/>
+                        <a:cs typeface="Calibri" charset="0"/>
+                      </a:endParaRPr>
+                    </a:p>
+                  </a:txBody>
+                  <a:tcPr marL="91440" marR="91440" marT="45720" marB="45720">
+                    <a:lnL w="6350" cap="flat" cmpd="sng" algn="ctr">
+                      <a:solidFill>
+                        <a:srgbClr val="D5DDE5"/>
+                      </a:solidFill>
+                      <a:prstDash val="solid"/>
+                      <a:round/>
+                      <a:headEnd type="none" w="med" len="med"/>
+                      <a:tailEnd type="none" w="med" len="med"/>
+                    </a:lnL>
+                    <a:lnR w="6350" cap="flat" cmpd="sng" algn="ctr">
+                      <a:solidFill>
+                        <a:srgbClr val="D5DDE5"/>
+                      </a:solidFill>
+                      <a:prstDash val="solid"/>
+                      <a:round/>
+                      <a:headEnd type="none" w="med" len="med"/>
+                      <a:tailEnd type="none" w="med" len="med"/>
+                    </a:lnR>
+                    <a:lnT w="6350" cap="flat" cmpd="sng" algn="ctr">
+                      <a:solidFill>
+                        <a:srgbClr val="D5DDE5"/>
+                      </a:solidFill>
+                      <a:prstDash val="solid"/>
+                      <a:round/>
+                      <a:headEnd type="none" w="med" len="med"/>
+                      <a:tailEnd type="none" w="med" len="med"/>
+                    </a:lnT>
+                    <a:lnB w="6350" cap="flat" cmpd="sng" algn="ctr">
+                      <a:solidFill>
+                        <a:srgbClr val="D5DDE5"/>
+                      </a:solidFill>
+                      <a:prstDash val="solid"/>
+                      <a:round/>
+                      <a:headEnd type="none" w="med" len="med"/>
+                      <a:tailEnd type="none" w="med" len="med"/>
+                    </a:lnB>
+                    <a:solidFill>
+                      <a:srgbClr val="DCE6F0"/>
+                    </a:solidFill>
+                  </a:tcPr>
+                </a:tc>
+                <a:tc>
+                  <a:txBody>
+                    <a:bodyPr/>
+                    <a:lstStyle/>
+                    <a:p>
+                      <a:pPr indent="0" marL="0">
+                        <a:buNone/>
+                      </a:pPr>
+                      <a:r>
+                        <a:rPr lang="en-US" sz="900" b="1" dirty="0">
+                          <a:solidFill>
+                            <a:srgbClr val="13315C"/>
+                          </a:solidFill>
+                          <a:latin typeface="Calibri" pitchFamily="34" charset="0"/>
+                          <a:ea typeface="Calibri" pitchFamily="34" charset="-122"/>
+                          <a:cs typeface="Calibri" pitchFamily="34" charset="-120"/>
+                        </a:rPr>
+                        <a:t>our generator — tested on</a:t>
+                      </a:r>
+                      <a:endParaRPr lang="en-US" sz="900" dirty="0">
+                        <a:latin typeface="Calibri" charset="0"/>
+                        <a:ea typeface="Calibri" charset="0"/>
+                        <a:cs typeface="Calibri" charset="0"/>
+                      </a:endParaRPr>
+                    </a:p>
+                  </a:txBody>
+                  <a:tcPr marL="91440" marR="91440" marT="45720" marB="45720">
+                    <a:lnL w="6350" cap="flat" cmpd="sng" algn="ctr">
+                      <a:solidFill>
+                        <a:srgbClr val="D5DDE5"/>
+                      </a:solidFill>
+                      <a:prstDash val="solid"/>
+                      <a:round/>
+                      <a:headEnd type="none" w="med" len="med"/>
+                      <a:tailEnd type="none" w="med" len="med"/>
+                    </a:lnL>
+                    <a:lnR w="6350" cap="flat" cmpd="sng" algn="ctr">
+                      <a:solidFill>
+                        <a:srgbClr val="D5DDE5"/>
+                      </a:solidFill>
+                      <a:prstDash val="solid"/>
+                      <a:round/>
+                      <a:headEnd type="none" w="med" len="med"/>
+                      <a:tailEnd type="none" w="med" len="med"/>
+                    </a:lnR>
+                    <a:lnT w="6350" cap="flat" cmpd="sng" algn="ctr">
+                      <a:solidFill>
+                        <a:srgbClr val="D5DDE5"/>
+                      </a:solidFill>
+                      <a:prstDash val="solid"/>
+                      <a:round/>
+                      <a:headEnd type="none" w="med" len="med"/>
+                      <a:tailEnd type="none" w="med" len="med"/>
+                    </a:lnT>
+                    <a:lnB w="6350" cap="flat" cmpd="sng" algn="ctr">
+                      <a:solidFill>
+                        <a:srgbClr val="D5DDE5"/>
+                      </a:solidFill>
+                      <a:prstDash val="solid"/>
+                      <a:round/>
+                      <a:headEnd type="none" w="med" len="med"/>
+                      <a:tailEnd type="none" w="med" len="med"/>
+                    </a:lnB>
+                    <a:solidFill>
+                      <a:srgbClr val="DCE6F0"/>
+                    </a:solidFill>
+                  </a:tcPr>
+                </a:tc>
+              </a:tr>
+              <a:tr h="274320">
+                <a:tc>
+                  <a:txBody>
+                    <a:bodyPr/>
+                    <a:lstStyle/>
+                    <a:p>
+                      <a:pPr indent="0" marL="0">
+                        <a:buNone/>
+                      </a:pPr>
+                      <a:r>
+                        <a:rPr lang="en-US" sz="900" b="1" dirty="0">
+                          <a:solidFill>
+                            <a:srgbClr val="13315C"/>
+                          </a:solidFill>
+                          <a:latin typeface="Calibri" pitchFamily="34" charset="0"/>
+                          <a:ea typeface="Calibri" pitchFamily="34" charset="-122"/>
+                          <a:cs typeface="Calibri" pitchFamily="34" charset="-120"/>
+                        </a:rPr>
+                        <a:t>pulse shaping</a:t>
+                      </a:r>
+                      <a:endParaRPr lang="en-US" sz="900" dirty="0">
+                        <a:latin typeface="Calibri" charset="0"/>
+                        <a:ea typeface="Calibri" charset="0"/>
+                        <a:cs typeface="Calibri" charset="0"/>
+                      </a:endParaRPr>
+                    </a:p>
+                  </a:txBody>
+                  <a:tcPr marL="91440" marR="91440" marT="45720" marB="45720">
+                    <a:lnL w="6350" cap="flat" cmpd="sng" algn="ctr">
+                      <a:solidFill>
+                        <a:srgbClr val="D5DDE5"/>
+                      </a:solidFill>
+                      <a:prstDash val="solid"/>
+                      <a:round/>
+                      <a:headEnd type="none" w="med" len="med"/>
+                      <a:tailEnd type="none" w="med" len="med"/>
+                    </a:lnL>
+                    <a:lnR w="6350" cap="flat" cmpd="sng" algn="ctr">
+                      <a:solidFill>
+                        <a:srgbClr val="D5DDE5"/>
+                      </a:solidFill>
+                      <a:prstDash val="solid"/>
+                      <a:round/>
+                      <a:headEnd type="none" w="med" len="med"/>
+                      <a:tailEnd type="none" w="med" len="med"/>
+                    </a:lnR>
+                    <a:lnT w="6350" cap="flat" cmpd="sng" algn="ctr">
+                      <a:solidFill>
+                        <a:srgbClr val="D5DDE5"/>
+                      </a:solidFill>
+                      <a:prstDash val="solid"/>
+                      <a:round/>
+                      <a:headEnd type="none" w="med" len="med"/>
+                      <a:tailEnd type="none" w="med" len="med"/>
+                    </a:lnT>
+                    <a:lnB w="6350" cap="flat" cmpd="sng" algn="ctr">
+                      <a:solidFill>
+                        <a:srgbClr val="D5DDE5"/>
+                      </a:solidFill>
+                      <a:prstDash val="solid"/>
+                      <a:round/>
+                      <a:headEnd type="none" w="med" len="med"/>
+                      <a:tailEnd type="none" w="med" len="med"/>
+                    </a:lnB>
+                  </a:tcPr>
+                </a:tc>
+                <a:tc>
+                  <a:txBody>
+                    <a:bodyPr/>
+                    <a:lstStyle/>
+                    <a:p>
+                      <a:pPr indent="0" marL="0">
+                        <a:buNone/>
+                      </a:pPr>
+                      <a:r>
+                        <a:rPr lang="en-US" sz="900" dirty="0">
+                          <a:solidFill>
+                            <a:srgbClr val="13315C"/>
+                          </a:solidFill>
+                          <a:latin typeface="Calibri" pitchFamily="34" charset="0"/>
+                          <a:ea typeface="Calibri" pitchFamily="34" charset="-122"/>
+                          <a:cs typeface="Calibri" pitchFamily="34" charset="-120"/>
+                        </a:rPr>
+                        <a:t>root-raised cosine, roll-off drawn per frame from U(0.1, 0.4)</a:t>
+                      </a:r>
+                      <a:endParaRPr lang="en-US" sz="900" dirty="0">
+                        <a:latin typeface="Calibri" charset="0"/>
+                        <a:ea typeface="Calibri" charset="0"/>
+                        <a:cs typeface="Calibri" charset="0"/>
+                      </a:endParaRPr>
+                    </a:p>
+                  </a:txBody>
+                  <a:tcPr marL="91440" marR="91440" marT="45720" marB="45720">
+                    <a:lnL w="6350" cap="flat" cmpd="sng" algn="ctr">
+                      <a:solidFill>
+                        <a:srgbClr val="D5DDE5"/>
+                      </a:solidFill>
+                      <a:prstDash val="solid"/>
+                      <a:round/>
+                      <a:headEnd type="none" w="med" len="med"/>
+                      <a:tailEnd type="none" w="med" len="med"/>
+                    </a:lnL>
+                    <a:lnR w="6350" cap="flat" cmpd="sng" algn="ctr">
+                      <a:solidFill>
+                        <a:srgbClr val="D5DDE5"/>
+                      </a:solidFill>
+                      <a:prstDash val="solid"/>
+                      <a:round/>
+                      <a:headEnd type="none" w="med" len="med"/>
+                      <a:tailEnd type="none" w="med" len="med"/>
+                    </a:lnR>
+                    <a:lnT w="6350" cap="flat" cmpd="sng" algn="ctr">
+                      <a:solidFill>
+                        <a:srgbClr val="D5DDE5"/>
+                      </a:solidFill>
+                      <a:prstDash val="solid"/>
+                      <a:round/>
+                      <a:headEnd type="none" w="med" len="med"/>
+                      <a:tailEnd type="none" w="med" len="med"/>
+                    </a:lnT>
+                    <a:lnB w="6350" cap="flat" cmpd="sng" algn="ctr">
+                      <a:solidFill>
+                        <a:srgbClr val="D5DDE5"/>
+                      </a:solidFill>
+                      <a:prstDash val="solid"/>
+                      <a:round/>
+                      <a:headEnd type="none" w="med" len="med"/>
+                      <a:tailEnd type="none" w="med" len="med"/>
+                    </a:lnB>
+                  </a:tcPr>
+                </a:tc>
+                <a:tc>
+                  <a:txBody>
+                    <a:bodyPr/>
+                    <a:lstStyle/>
+                    <a:p>
+                      <a:pPr indent="0" marL="0">
+                        <a:buNone/>
+                      </a:pPr>
+                      <a:r>
+                        <a:rPr lang="en-US" sz="900" dirty="0">
+                          <a:solidFill>
+                            <a:srgbClr val="13315C"/>
+                          </a:solidFill>
+                          <a:latin typeface="Calibri" pitchFamily="34" charset="0"/>
+                          <a:ea typeface="Calibri" pitchFamily="34" charset="-122"/>
+                          <a:cs typeface="Calibri" pitchFamily="34" charset="-120"/>
+                        </a:rPr>
+                        <a:t>root-raised cosine, roll-off fixed at 0.35</a:t>
+                      </a:r>
+                      <a:endParaRPr lang="en-US" sz="900" dirty="0">
+                        <a:latin typeface="Calibri" charset="0"/>
+                        <a:ea typeface="Calibri" charset="0"/>
+                        <a:cs typeface="Calibri" charset="0"/>
+                      </a:endParaRPr>
+                    </a:p>
+                  </a:txBody>
+                  <a:tcPr marL="91440" marR="91440" marT="45720" marB="45720">
+                    <a:lnL w="6350" cap="flat" cmpd="sng" algn="ctr">
+                      <a:solidFill>
+                        <a:srgbClr val="D5DDE5"/>
+                      </a:solidFill>
+                      <a:prstDash val="solid"/>
+                      <a:round/>
+                      <a:headEnd type="none" w="med" len="med"/>
+                      <a:tailEnd type="none" w="med" len="med"/>
+                    </a:lnL>
+                    <a:lnR w="6350" cap="flat" cmpd="sng" algn="ctr">
+                      <a:solidFill>
+                        <a:srgbClr val="D5DDE5"/>
+                      </a:solidFill>
+                      <a:prstDash val="solid"/>
+                      <a:round/>
+                      <a:headEnd type="none" w="med" len="med"/>
+                      <a:tailEnd type="none" w="med" len="med"/>
+                    </a:lnR>
+                    <a:lnT w="6350" cap="flat" cmpd="sng" algn="ctr">
+                      <a:solidFill>
+                        <a:srgbClr val="D5DDE5"/>
+                      </a:solidFill>
+                      <a:prstDash val="solid"/>
+                      <a:round/>
+                      <a:headEnd type="none" w="med" len="med"/>
+                      <a:tailEnd type="none" w="med" len="med"/>
+                    </a:lnT>
+                    <a:lnB w="6350" cap="flat" cmpd="sng" algn="ctr">
+                      <a:solidFill>
+                        <a:srgbClr val="D5DDE5"/>
+                      </a:solidFill>
+                      <a:prstDash val="solid"/>
+                      <a:round/>
+                      <a:headEnd type="none" w="med" len="med"/>
+                      <a:tailEnd type="none" w="med" len="med"/>
+                    </a:lnB>
+                  </a:tcPr>
+                </a:tc>
+              </a:tr>
+              <a:tr h="274320">
+                <a:tc>
+                  <a:txBody>
+                    <a:bodyPr/>
+                    <a:lstStyle/>
+                    <a:p>
+                      <a:pPr indent="0" marL="0">
+                        <a:buNone/>
+                      </a:pPr>
+                      <a:r>
+                        <a:rPr lang="en-US" sz="900" b="1" dirty="0">
+                          <a:solidFill>
+                            <a:srgbClr val="13315C"/>
+                          </a:solidFill>
+                          <a:latin typeface="Calibri" pitchFamily="34" charset="0"/>
+                          <a:ea typeface="Calibri" pitchFamily="34" charset="-122"/>
+                          <a:cs typeface="Calibri" pitchFamily="34" charset="-120"/>
+                        </a:rPr>
+                        <a:t>channel</a:t>
+                      </a:r>
+                      <a:endParaRPr lang="en-US" sz="900" dirty="0">
+                        <a:latin typeface="Calibri" charset="0"/>
+                        <a:ea typeface="Calibri" charset="0"/>
+                        <a:cs typeface="Calibri" charset="0"/>
+                      </a:endParaRPr>
+                    </a:p>
+                  </a:txBody>
+                  <a:tcPr marL="91440" marR="91440" marT="45720" marB="45720">
+                    <a:lnL w="6350" cap="flat" cmpd="sng" algn="ctr">
+                      <a:solidFill>
+                        <a:srgbClr val="D5DDE5"/>
+                      </a:solidFill>
+                      <a:prstDash val="solid"/>
+                      <a:round/>
+                      <a:headEnd type="none" w="med" len="med"/>
+                      <a:tailEnd type="none" w="med" len="med"/>
+                    </a:lnL>
+                    <a:lnR w="6350" cap="flat" cmpd="sng" algn="ctr">
+                      <a:solidFill>
+                        <a:srgbClr val="D5DDE5"/>
+                      </a:solidFill>
+                      <a:prstDash val="solid"/>
+                      <a:round/>
+                      <a:headEnd type="none" w="med" len="med"/>
+                      <a:tailEnd type="none" w="med" len="med"/>
+                    </a:lnR>
+                    <a:lnT w="6350" cap="flat" cmpd="sng" algn="ctr">
+                      <a:solidFill>
+                        <a:srgbClr val="D5DDE5"/>
+                      </a:solidFill>
+                      <a:prstDash val="solid"/>
+                      <a:round/>
+                      <a:headEnd type="none" w="med" len="med"/>
+                      <a:tailEnd type="none" w="med" len="med"/>
+                    </a:lnT>
+                    <a:lnB w="6350" cap="flat" cmpd="sng" algn="ctr">
+                      <a:solidFill>
+                        <a:srgbClr val="D5DDE5"/>
+                      </a:solidFill>
+                      <a:prstDash val="solid"/>
+                      <a:round/>
+                      <a:headEnd type="none" w="med" len="med"/>
+                      <a:tailEnd type="none" w="med" len="med"/>
+                    </a:lnB>
+                  </a:tcPr>
+                </a:tc>
+                <a:tc>
+                  <a:txBody>
+                    <a:bodyPr/>
+                    <a:lstStyle/>
+                    <a:p>
+                      <a:pPr indent="0" marL="0">
+                        <a:buNone/>
+                      </a:pPr>
+                      <a:r>
+                        <a:rPr lang="en-US" sz="900" dirty="0">
+                          <a:solidFill>
+                            <a:srgbClr val="13315C"/>
+                          </a:solidFill>
+                          <a:latin typeface="Calibri" pitchFamily="34" charset="0"/>
+                          <a:ea typeface="Calibri" pitchFamily="34" charset="-122"/>
+                          <a:cs typeface="Calibri" pitchFamily="34" charset="-120"/>
+                        </a:rPr>
+                        <a:t>carrier, clock and timing offsets; Rayleigh multipath</a:t>
+                      </a:r>
+                      <a:endParaRPr lang="en-US" sz="900" dirty="0">
+                        <a:latin typeface="Calibri" charset="0"/>
+                        <a:ea typeface="Calibri" charset="0"/>
+                        <a:cs typeface="Calibri" charset="0"/>
+                      </a:endParaRPr>
+                    </a:p>
+                  </a:txBody>
+                  <a:tcPr marL="91440" marR="91440" marT="45720" marB="45720">
+                    <a:lnL w="6350" cap="flat" cmpd="sng" algn="ctr">
+                      <a:solidFill>
+                        <a:srgbClr val="D5DDE5"/>
+                      </a:solidFill>
+                      <a:prstDash val="solid"/>
+                      <a:round/>
+                      <a:headEnd type="none" w="med" len="med"/>
+                      <a:tailEnd type="none" w="med" len="med"/>
+                    </a:lnL>
+                    <a:lnR w="6350" cap="flat" cmpd="sng" algn="ctr">
+                      <a:solidFill>
+                        <a:srgbClr val="D5DDE5"/>
+                      </a:solidFill>
+                      <a:prstDash val="solid"/>
+                      <a:round/>
+                      <a:headEnd type="none" w="med" len="med"/>
+                      <a:tailEnd type="none" w="med" len="med"/>
+                    </a:lnR>
+                    <a:lnT w="6350" cap="flat" cmpd="sng" algn="ctr">
+                      <a:solidFill>
+                        <a:srgbClr val="D5DDE5"/>
+                      </a:solidFill>
+                      <a:prstDash val="solid"/>
+                      <a:round/>
+                      <a:headEnd type="none" w="med" len="med"/>
+                      <a:tailEnd type="none" w="med" len="med"/>
+                    </a:lnT>
+                    <a:lnB w="6350" cap="flat" cmpd="sng" algn="ctr">
+                      <a:solidFill>
+                        <a:srgbClr val="D5DDE5"/>
+                      </a:solidFill>
+                      <a:prstDash val="solid"/>
+                      <a:round/>
+                      <a:headEnd type="none" w="med" len="med"/>
+                      <a:tailEnd type="none" w="med" len="med"/>
+                    </a:lnB>
+                  </a:tcPr>
+                </a:tc>
+                <a:tc>
+                  <a:txBody>
+                    <a:bodyPr/>
+                    <a:lstStyle/>
+                    <a:p>
+                      <a:pPr indent="0" marL="0">
+                        <a:buNone/>
+                      </a:pPr>
+                      <a:r>
+                        <a:rPr lang="en-US" sz="900" dirty="0">
+                          <a:solidFill>
+                            <a:srgbClr val="13315C"/>
+                          </a:solidFill>
+                          <a:latin typeface="Calibri" pitchFamily="34" charset="0"/>
+                          <a:ea typeface="Calibri" pitchFamily="34" charset="-122"/>
+                          <a:cs typeface="Calibri" pitchFamily="34" charset="-120"/>
+                        </a:rPr>
+                        <a:t>none</a:t>
+                      </a:r>
+                      <a:endParaRPr lang="en-US" sz="900" dirty="0">
+                        <a:latin typeface="Calibri" charset="0"/>
+                        <a:ea typeface="Calibri" charset="0"/>
+                        <a:cs typeface="Calibri" charset="0"/>
+                      </a:endParaRPr>
+                    </a:p>
+                  </a:txBody>
+                  <a:tcPr marL="91440" marR="91440" marT="45720" marB="45720">
+                    <a:lnL w="6350" cap="flat" cmpd="sng" algn="ctr">
+                      <a:solidFill>
+                        <a:srgbClr val="D5DDE5"/>
+                      </a:solidFill>
+                      <a:prstDash val="solid"/>
+                      <a:round/>
+                      <a:headEnd type="none" w="med" len="med"/>
+                      <a:tailEnd type="none" w="med" len="med"/>
+                    </a:lnL>
+                    <a:lnR w="6350" cap="flat" cmpd="sng" algn="ctr">
+                      <a:solidFill>
+                        <a:srgbClr val="D5DDE5"/>
+                      </a:solidFill>
+                      <a:prstDash val="solid"/>
+                      <a:round/>
+                      <a:headEnd type="none" w="med" len="med"/>
+                      <a:tailEnd type="none" w="med" len="med"/>
+                    </a:lnR>
+                    <a:lnT w="6350" cap="flat" cmpd="sng" algn="ctr">
+                      <a:solidFill>
+                        <a:srgbClr val="D5DDE5"/>
+                      </a:solidFill>
+                      <a:prstDash val="solid"/>
+                      <a:round/>
+                      <a:headEnd type="none" w="med" len="med"/>
+                      <a:tailEnd type="none" w="med" len="med"/>
+                    </a:lnT>
+                    <a:lnB w="6350" cap="flat" cmpd="sng" algn="ctr">
+                      <a:solidFill>
+                        <a:srgbClr val="D5DDE5"/>
+                      </a:solidFill>
+                      <a:prstDash val="solid"/>
+                      <a:round/>
+                      <a:headEnd type="none" w="med" len="med"/>
+                      <a:tailEnd type="none" w="med" len="med"/>
+                    </a:lnB>
+                  </a:tcPr>
+                </a:tc>
+              </a:tr>
+              <a:tr h="274320">
+                <a:tc>
+                  <a:txBody>
+                    <a:bodyPr/>
+                    <a:lstStyle/>
+                    <a:p>
+                      <a:pPr indent="0" marL="0">
+                        <a:buNone/>
+                      </a:pPr>
+                      <a:r>
+                        <a:rPr lang="en-US" sz="900" b="1" dirty="0">
+                          <a:solidFill>
+                            <a:srgbClr val="13315C"/>
+                          </a:solidFill>
+                          <a:latin typeface="Calibri" pitchFamily="34" charset="0"/>
+                          <a:ea typeface="Calibri" pitchFamily="34" charset="-122"/>
+                          <a:cs typeface="Calibri" pitchFamily="34" charset="-120"/>
+                        </a:rPr>
+                        <a:t>noise</a:t>
+                      </a:r>
+                      <a:endParaRPr lang="en-US" sz="900" dirty="0">
+                        <a:latin typeface="Calibri" charset="0"/>
+                        <a:ea typeface="Calibri" charset="0"/>
+                        <a:cs typeface="Calibri" charset="0"/>
+                      </a:endParaRPr>
+                    </a:p>
+                  </a:txBody>
+                  <a:tcPr marL="91440" marR="91440" marT="45720" marB="45720">
+                    <a:lnL w="6350" cap="flat" cmpd="sng" algn="ctr">
+                      <a:solidFill>
+                        <a:srgbClr val="D5DDE5"/>
+                      </a:solidFill>
+                      <a:prstDash val="solid"/>
+                      <a:round/>
+                      <a:headEnd type="none" w="med" len="med"/>
+                      <a:tailEnd type="none" w="med" len="med"/>
+                    </a:lnL>
+                    <a:lnR w="6350" cap="flat" cmpd="sng" algn="ctr">
+                      <a:solidFill>
+                        <a:srgbClr val="D5DDE5"/>
+                      </a:solidFill>
+                      <a:prstDash val="solid"/>
+                      <a:round/>
+                      <a:headEnd type="none" w="med" len="med"/>
+                      <a:tailEnd type="none" w="med" len="med"/>
+                    </a:lnR>
+                    <a:lnT w="6350" cap="flat" cmpd="sng" algn="ctr">
+                      <a:solidFill>
+                        <a:srgbClr val="D5DDE5"/>
+                      </a:solidFill>
+                      <a:prstDash val="solid"/>
+                      <a:round/>
+                      <a:headEnd type="none" w="med" len="med"/>
+                      <a:tailEnd type="none" w="med" len="med"/>
+                    </a:lnT>
+                    <a:lnB w="6350" cap="flat" cmpd="sng" algn="ctr">
+                      <a:solidFill>
+                        <a:srgbClr val="D5DDE5"/>
+                      </a:solidFill>
+                      <a:prstDash val="solid"/>
+                      <a:round/>
+                      <a:headEnd type="none" w="med" len="med"/>
+                      <a:tailEnd type="none" w="med" len="med"/>
+                    </a:lnB>
+                  </a:tcPr>
+                </a:tc>
+                <a:tc>
+                  <a:txBody>
+                    <a:bodyPr/>
+                    <a:lstStyle/>
+                    <a:p>
+                      <a:pPr indent="0" marL="0">
+                        <a:buNone/>
+                      </a:pPr>
+                      <a:r>
+                        <a:rPr lang="en-US" sz="900" dirty="0">
+                          <a:solidFill>
+                            <a:srgbClr val="13315C"/>
+                          </a:solidFill>
+                          <a:latin typeface="Calibri" pitchFamily="34" charset="0"/>
+                          <a:ea typeface="Calibri" pitchFamily="34" charset="-122"/>
+                          <a:cs typeface="Calibri" pitchFamily="34" charset="-120"/>
+                        </a:rPr>
+                        <a:t>AWGN, −20 to +30 dB</a:t>
+                      </a:r>
+                      <a:endParaRPr lang="en-US" sz="900" dirty="0">
+                        <a:latin typeface="Calibri" charset="0"/>
+                        <a:ea typeface="Calibri" charset="0"/>
+                        <a:cs typeface="Calibri" charset="0"/>
+                      </a:endParaRPr>
+                    </a:p>
+                  </a:txBody>
+                  <a:tcPr marL="91440" marR="91440" marT="45720" marB="45720">
+                    <a:lnL w="6350" cap="flat" cmpd="sng" algn="ctr">
+                      <a:solidFill>
+                        <a:srgbClr val="D5DDE5"/>
+                      </a:solidFill>
+                      <a:prstDash val="solid"/>
+                      <a:round/>
+                      <a:headEnd type="none" w="med" len="med"/>
+                      <a:tailEnd type="none" w="med" len="med"/>
+                    </a:lnL>
+                    <a:lnR w="6350" cap="flat" cmpd="sng" algn="ctr">
+                      <a:solidFill>
+                        <a:srgbClr val="D5DDE5"/>
+                      </a:solidFill>
+                      <a:prstDash val="solid"/>
+                      <a:round/>
+                      <a:headEnd type="none" w="med" len="med"/>
+                      <a:tailEnd type="none" w="med" len="med"/>
+                    </a:lnR>
+                    <a:lnT w="6350" cap="flat" cmpd="sng" algn="ctr">
+                      <a:solidFill>
+                        <a:srgbClr val="D5DDE5"/>
+                      </a:solidFill>
+                      <a:prstDash val="solid"/>
+                      <a:round/>
+                      <a:headEnd type="none" w="med" len="med"/>
+                      <a:tailEnd type="none" w="med" len="med"/>
+                    </a:lnT>
+                    <a:lnB w="6350" cap="flat" cmpd="sng" algn="ctr">
+                      <a:solidFill>
+                        <a:srgbClr val="D5DDE5"/>
+                      </a:solidFill>
+                      <a:prstDash val="solid"/>
+                      <a:round/>
+                      <a:headEnd type="none" w="med" len="med"/>
+                      <a:tailEnd type="none" w="med" len="med"/>
+                    </a:lnB>
+                  </a:tcPr>
+                </a:tc>
+                <a:tc>
+                  <a:txBody>
+                    <a:bodyPr/>
+                    <a:lstStyle/>
+                    <a:p>
+                      <a:pPr indent="0" marL="0">
+                        <a:buNone/>
+                      </a:pPr>
+                      <a:r>
+                        <a:rPr lang="en-US" sz="900" dirty="0">
+                          <a:solidFill>
+                            <a:srgbClr val="13315C"/>
+                          </a:solidFill>
+                          <a:latin typeface="Calibri" pitchFamily="34" charset="0"/>
+                          <a:ea typeface="Calibri" pitchFamily="34" charset="-122"/>
+                          <a:cs typeface="Calibri" pitchFamily="34" charset="-120"/>
+                        </a:rPr>
+                        <a:t>AWGN, same grid</a:t>
+                      </a:r>
+                      <a:endParaRPr lang="en-US" sz="900" dirty="0">
+                        <a:latin typeface="Calibri" charset="0"/>
+                        <a:ea typeface="Calibri" charset="0"/>
+                        <a:cs typeface="Calibri" charset="0"/>
+                      </a:endParaRPr>
+                    </a:p>
+                  </a:txBody>
+                  <a:tcPr marL="91440" marR="91440" marT="45720" marB="45720">
+                    <a:lnL w="6350" cap="flat" cmpd="sng" algn="ctr">
+                      <a:solidFill>
+                        <a:srgbClr val="D5DDE5"/>
+                      </a:solidFill>
+                      <a:prstDash val="solid"/>
+                      <a:round/>
+                      <a:headEnd type="none" w="med" len="med"/>
+                      <a:tailEnd type="none" w="med" len="med"/>
+                    </a:lnL>
+                    <a:lnR w="6350" cap="flat" cmpd="sng" algn="ctr">
+                      <a:solidFill>
+                        <a:srgbClr val="D5DDE5"/>
+                      </a:solidFill>
+                      <a:prstDash val="solid"/>
+                      <a:round/>
+                      <a:headEnd type="none" w="med" len="med"/>
+                      <a:tailEnd type="none" w="med" len="med"/>
+                    </a:lnR>
+                    <a:lnT w="6350" cap="flat" cmpd="sng" algn="ctr">
+                      <a:solidFill>
+                        <a:srgbClr val="D5DDE5"/>
+                      </a:solidFill>
+                      <a:prstDash val="solid"/>
+                      <a:round/>
+                      <a:headEnd type="none" w="med" len="med"/>
+                      <a:tailEnd type="none" w="med" len="med"/>
+                    </a:lnT>
+                    <a:lnB w="6350" cap="flat" cmpd="sng" algn="ctr">
+                      <a:solidFill>
+                        <a:srgbClr val="D5DDE5"/>
+                      </a:solidFill>
+                      <a:prstDash val="solid"/>
+                      <a:round/>
+                      <a:headEnd type="none" w="med" len="med"/>
+                      <a:tailEnd type="none" w="med" len="med"/>
+                    </a:lnB>
+                  </a:tcPr>
+                </a:tc>
+              </a:tr>
+            </a:tbl>
+          </a:graphicData>
+        </a:graphic>
+      </p:graphicFrame>
       <p:sp>
         <p:nvSpPr>
-          <p:cNvPr id="11" name="Text 9"/>
+          <p:cNvPr id="12" name="Text 9"/>
           <p:cNvSpPr txBox="1"/>
           <p:nvPr/>
         </p:nvSpPr>
@@ -18933,7 +19750,7 @@
       </p:sp>
       <p:sp>
         <p:nvSpPr>
-          <p:cNvPr id="12" name="Shape 10"/>
+          <p:cNvPr id="13" name="Shape 10"/>
           <p:cNvSpPr/>
           <p:nvPr/>
         </p:nvSpPr>
@@ -18958,7 +19775,7 @@
       </p:sp>
       <p:sp>
         <p:nvSpPr>
-          <p:cNvPr id="13" name="Text 11"/>
+          <p:cNvPr id="14" name="Text 11"/>
           <p:cNvSpPr txBox="1"/>
           <p:nvPr/>
         </p:nvSpPr>
@@ -18997,7 +19814,7 @@
       </p:sp>
       <p:sp>
         <p:nvSpPr>
-          <p:cNvPr id="14" name="Text 12"/>
+          <p:cNvPr id="15" name="Text 12"/>
           <p:cNvSpPr txBox="1"/>
           <p:nvPr/>
         </p:nvSpPr>
@@ -19036,7 +19853,7 @@
       </p:sp>
       <p:sp>
         <p:nvSpPr>
-          <p:cNvPr id="15" name="Shape 13"/>
+          <p:cNvPr id="16" name="Shape 13"/>
           <p:cNvSpPr/>
           <p:nvPr/>
         </p:nvSpPr>
@@ -19061,7 +19878,7 @@
       </p:sp>
       <p:sp>
         <p:nvSpPr>
-          <p:cNvPr id="16" name="Text 14"/>
+          <p:cNvPr id="17" name="Text 14"/>
           <p:cNvSpPr txBox="1"/>
           <p:nvPr/>
         </p:nvSpPr>
@@ -19100,7 +19917,7 @@
       </p:sp>
       <p:sp>
         <p:nvSpPr>
-          <p:cNvPr id="17" name="Text 15"/>
+          <p:cNvPr id="18" name="Text 15"/>
           <p:cNvSpPr txBox="1"/>
           <p:nvPr/>
         </p:nvSpPr>
@@ -19139,7 +19956,7 @@
       </p:sp>
       <p:sp>
         <p:nvSpPr>
-          <p:cNvPr id="18" name="Shape 16"/>
+          <p:cNvPr id="19" name="Shape 16"/>
           <p:cNvSpPr/>
           <p:nvPr/>
         </p:nvSpPr>
@@ -19164,7 +19981,7 @@
       </p:sp>
       <p:sp>
         <p:nvSpPr>
-          <p:cNvPr id="19" name="Text 17"/>
+          <p:cNvPr id="20" name="Text 17"/>
           <p:cNvSpPr txBox="1"/>
           <p:nvPr/>
         </p:nvSpPr>
@@ -19203,7 +20020,7 @@
       </p:sp>
       <p:sp>
         <p:nvSpPr>
-          <p:cNvPr id="20" name="Text 18"/>
+          <p:cNvPr id="21" name="Text 18"/>
           <p:cNvSpPr txBox="1"/>
           <p:nvPr/>
         </p:nvSpPr>
@@ -19242,7 +20059,7 @@
       </p:sp>
       <p:sp>
         <p:nvSpPr>
-          <p:cNvPr id="21" name="Shape 19"/>
+          <p:cNvPr id="22" name="Shape 19"/>
           <p:cNvSpPr/>
           <p:nvPr/>
         </p:nvSpPr>
@@ -19267,7 +20084,7 @@
       </p:sp>
       <p:sp>
         <p:nvSpPr>
-          <p:cNvPr id="22" name="Text 20"/>
+          <p:cNvPr id="23" name="Text 20"/>
           <p:cNvSpPr txBox="1"/>
           <p:nvPr/>
         </p:nvSpPr>
@@ -19306,7 +20123,7 @@
       </p:sp>
       <p:sp>
         <p:nvSpPr>
-          <p:cNvPr id="23" name="Text 21"/>
+          <p:cNvPr id="24" name="Text 21"/>
           <p:cNvSpPr txBox="1"/>
           <p:nvPr/>
         </p:nvSpPr>
@@ -19345,7 +20162,7 @@
       </p:sp>
       <p:sp>
         <p:nvSpPr>
-          <p:cNvPr id="25" name="Text 22"/>
+          <p:cNvPr id="26" name="Text 22"/>
           <p:cNvSpPr txBox="1"/>
           <p:nvPr/>
         </p:nvSpPr>

</xml_diff>